<commit_message>
push notes on replication paper
</commit_message>
<xml_diff>
--- a/project_presentation.pptx
+++ b/project_presentation.pptx
@@ -11693,11 +11693,7 @@
             <a:pPr marL="228600"/>
             <a:r>
               <a:rPr lang="en-US" b="1" noProof="0" dirty="0"/>
-              <a:t>Appl</a:t>
-            </a:r>
-            <a:r>
-              <a:rPr lang="en-US" b="1" dirty="0" err="1"/>
-              <a:t>ication</a:t>
+              <a:t>Analysis</a:t>
             </a:r>
             <a:r>
               <a:rPr lang="en-US" b="1" dirty="0"/>
@@ -11710,8 +11706,8 @@
               <a:buChar char="•"/>
             </a:pPr>
             <a:r>
-              <a:rPr lang="en-US" noProof="0" dirty="0"/>
-              <a:t>How did German parties’ sentiment change during the 2025 Bundestag campaign?</a:t>
+              <a:rPr lang="en-US" dirty="0"/>
+              <a:t>How does communication change between non-election campaign and campaign times?</a:t>
             </a:r>
           </a:p>
           <a:p>
@@ -11721,16 +11717,22 @@
             </a:pPr>
             <a:r>
               <a:rPr lang="en-US" dirty="0"/>
-              <a:t>Analyze individual politicians’ communication on social media (Bluesky posts)</a:t>
+              <a:t>How </a:t>
             </a:r>
-            <a:endParaRPr lang="en-US" noProof="0" dirty="0"/>
+            <a:r>
+              <a:rPr lang="en-US" noProof="0" dirty="0"/>
+              <a:t>did German parties’ sentiment change during the 2025 Bundestag campaign?</a:t>
+            </a:r>
           </a:p>
           <a:p>
             <a:pPr marL="514350" indent="-285750">
               <a:buFont typeface="Arial" panose="020B0604020202020204" pitchFamily="34" charset="0"/>
               <a:buChar char="•"/>
             </a:pPr>
-            <a:endParaRPr lang="en-US" noProof="0" dirty="0"/>
+            <a:r>
+              <a:rPr lang="en-US" dirty="0"/>
+              <a:t>Analyze individual politicians’ communication on social media, sentiment analysis on Bluesky posts</a:t>
+            </a:r>
           </a:p>
         </p:txBody>
       </p:sp>
@@ -12224,7 +12226,7 @@
             </a:r>
             <a:r>
               <a:rPr lang="en-US" dirty="0"/>
-              <a:t>dictionary-sentiment analysis</a:t>
+              <a:t>dictionary-based sentiment analysis</a:t>
             </a:r>
           </a:p>
           <a:p>
@@ -12255,11 +12257,11 @@
             </a:pPr>
             <a:r>
               <a:rPr lang="en-US" noProof="0" dirty="0"/>
-              <a:t>That gap narrows during </a:t>
+              <a:t>This gap narrows during </a:t>
             </a:r>
             <a:r>
               <a:rPr lang="en-US" dirty="0"/>
-              <a:t>election campaigns. This effect holds even for Euroskeptic</a:t>
+              <a:t>election campaigns. The effect holds even for Euroskeptic</a:t>
             </a:r>
             <a:br>
               <a:rPr lang="en-US" dirty="0"/>
@@ -12700,12 +12702,13 @@
             </a:lvl9pPr>
           </a:lstStyle>
           <a:p>
-            <a:pPr marL="514350" indent="-285750">
-              <a:buFont typeface="Arial" panose="020B0604020202020204" pitchFamily="34" charset="0"/>
-              <a:buChar char="•"/>
-            </a:pPr>
+            <a:pPr marL="228600"/>
             <a:r>
-              <a:rPr lang="en-US" noProof="0" dirty="0"/>
+              <a:rPr lang="en-US" noProof="0" dirty="0">
+                <a:solidFill>
+                  <a:schemeClr val="accent2"/>
+                </a:solidFill>
+              </a:rPr>
               <a:t>Test if the authors’ findings can be applied to the 2025 German Bundestag campaign</a:t>
             </a:r>
           </a:p>
@@ -13887,422 +13890,110 @@
           <a:p>
             <a:pPr marL="228600"/>
             <a:r>
-              <a:rPr lang="de-DE" dirty="0"/>
+              <a:rPr lang="en-US" noProof="0" dirty="0"/>
               <a:t>Crabtree, C., Golder, M., Gschwend, T., &amp; </a:t>
             </a:r>
             <a:r>
-              <a:rPr lang="de-DE" dirty="0" err="1"/>
+              <a:rPr lang="en-US" noProof="0" dirty="0" err="1"/>
               <a:t>Indriđason</a:t>
             </a:r>
             <a:r>
-              <a:rPr lang="de-DE" dirty="0"/>
-              <a:t>, I. H. (2020). </a:t>
+              <a:rPr lang="en-US" noProof="0" dirty="0"/>
+              <a:t>, I. H. (2020). It is not only what you say, it is also how you say it: The strategic use of campaign sentiment. </a:t>
             </a:r>
             <a:r>
-              <a:rPr lang="de-DE" dirty="0" err="1"/>
-              <a:t>It</a:t>
+              <a:rPr lang="en-US" i="1" noProof="0" dirty="0"/>
+              <a:t>The Journal of Politics</a:t>
             </a:r>
             <a:r>
-              <a:rPr lang="de-DE" dirty="0"/>
-              <a:t> </a:t>
-            </a:r>
-            <a:r>
-              <a:rPr lang="de-DE" dirty="0" err="1"/>
-              <a:t>is</a:t>
-            </a:r>
-            <a:r>
-              <a:rPr lang="de-DE" dirty="0"/>
-              <a:t> not </a:t>
-            </a:r>
-            <a:r>
-              <a:rPr lang="de-DE" dirty="0" err="1"/>
-              <a:t>only</a:t>
-            </a:r>
-            <a:r>
-              <a:rPr lang="de-DE" dirty="0"/>
-              <a:t> </a:t>
-            </a:r>
-            <a:r>
-              <a:rPr lang="de-DE" dirty="0" err="1"/>
-              <a:t>what</a:t>
-            </a:r>
-            <a:r>
-              <a:rPr lang="de-DE" dirty="0"/>
-              <a:t> </a:t>
-            </a:r>
-            <a:r>
-              <a:rPr lang="de-DE" dirty="0" err="1"/>
-              <a:t>you</a:t>
-            </a:r>
-            <a:r>
-              <a:rPr lang="de-DE" dirty="0"/>
-              <a:t> </a:t>
-            </a:r>
-            <a:r>
-              <a:rPr lang="de-DE" dirty="0" err="1"/>
-              <a:t>say</a:t>
-            </a:r>
-            <a:r>
-              <a:rPr lang="de-DE" dirty="0"/>
-              <a:t>, </a:t>
-            </a:r>
-            <a:r>
-              <a:rPr lang="de-DE" dirty="0" err="1"/>
-              <a:t>it</a:t>
-            </a:r>
-            <a:r>
-              <a:rPr lang="de-DE" dirty="0"/>
-              <a:t> </a:t>
-            </a:r>
-            <a:r>
-              <a:rPr lang="de-DE" dirty="0" err="1"/>
-              <a:t>is</a:t>
-            </a:r>
-            <a:r>
-              <a:rPr lang="de-DE" dirty="0"/>
-              <a:t> also </a:t>
-            </a:r>
-            <a:r>
-              <a:rPr lang="de-DE" dirty="0" err="1"/>
-              <a:t>how</a:t>
-            </a:r>
-            <a:r>
-              <a:rPr lang="de-DE" dirty="0"/>
-              <a:t> </a:t>
-            </a:r>
-            <a:r>
-              <a:rPr lang="de-DE" dirty="0" err="1"/>
-              <a:t>you</a:t>
-            </a:r>
-            <a:r>
-              <a:rPr lang="de-DE" dirty="0"/>
-              <a:t> </a:t>
-            </a:r>
-            <a:r>
-              <a:rPr lang="de-DE" dirty="0" err="1"/>
-              <a:t>say</a:t>
-            </a:r>
-            <a:r>
-              <a:rPr lang="de-DE" dirty="0"/>
-              <a:t> </a:t>
-            </a:r>
-            <a:r>
-              <a:rPr lang="de-DE" dirty="0" err="1"/>
-              <a:t>it</a:t>
-            </a:r>
-            <a:r>
-              <a:rPr lang="de-DE" dirty="0"/>
-              <a:t>: The </a:t>
-            </a:r>
-            <a:r>
-              <a:rPr lang="de-DE" dirty="0" err="1"/>
-              <a:t>strategic</a:t>
-            </a:r>
-            <a:r>
-              <a:rPr lang="de-DE" dirty="0"/>
-              <a:t> </a:t>
-            </a:r>
-            <a:r>
-              <a:rPr lang="de-DE" dirty="0" err="1"/>
-              <a:t>use</a:t>
-            </a:r>
-            <a:r>
-              <a:rPr lang="de-DE" dirty="0"/>
-              <a:t> </a:t>
-            </a:r>
-            <a:r>
-              <a:rPr lang="de-DE" dirty="0" err="1"/>
-              <a:t>of</a:t>
-            </a:r>
-            <a:r>
-              <a:rPr lang="de-DE" dirty="0"/>
-              <a:t> </a:t>
-            </a:r>
-            <a:r>
-              <a:rPr lang="de-DE" dirty="0" err="1"/>
-              <a:t>campaign</a:t>
-            </a:r>
-            <a:r>
-              <a:rPr lang="de-DE" dirty="0"/>
-              <a:t> </a:t>
-            </a:r>
-            <a:r>
-              <a:rPr lang="de-DE" dirty="0" err="1"/>
-              <a:t>sentiment</a:t>
-            </a:r>
-            <a:r>
-              <a:rPr lang="de-DE" dirty="0"/>
-              <a:t>. </a:t>
-            </a:r>
-            <a:r>
-              <a:rPr lang="de-DE" i="1" dirty="0"/>
-              <a:t>The Journal </a:t>
-            </a:r>
-            <a:r>
-              <a:rPr lang="de-DE" i="1" dirty="0" err="1"/>
-              <a:t>of</a:t>
-            </a:r>
-            <a:r>
-              <a:rPr lang="de-DE" i="1" dirty="0"/>
-              <a:t> Politics</a:t>
-            </a:r>
-            <a:r>
-              <a:rPr lang="de-DE" dirty="0"/>
+              <a:rPr lang="en-US" noProof="0" dirty="0"/>
               <a:t>, </a:t>
             </a:r>
             <a:r>
-              <a:rPr lang="de-DE" i="1" dirty="0"/>
+              <a:rPr lang="en-US" i="1" noProof="0" dirty="0"/>
               <a:t>82</a:t>
             </a:r>
             <a:r>
-              <a:rPr lang="de-DE" dirty="0"/>
+              <a:rPr lang="en-US" noProof="0" dirty="0"/>
               <a:t>(3), 1044-1060.</a:t>
             </a:r>
             <a:br>
-              <a:rPr lang="de-DE" dirty="0"/>
+              <a:rPr lang="en-US" noProof="0" dirty="0"/>
             </a:br>
             <a:br>
-              <a:rPr lang="de-DE" dirty="0"/>
+              <a:rPr lang="en-US" noProof="0" dirty="0"/>
             </a:br>
             <a:r>
-              <a:rPr lang="de-DE" dirty="0"/>
-              <a:t>Marchal, N. (2022). “Be nice </a:t>
+              <a:rPr lang="en-US" noProof="0" dirty="0"/>
+              <a:t>Marchal, N. (2022). “Be nice or leave me alone”: An intergroup perspective on affective polarization in online political discussions. </a:t>
             </a:r>
             <a:r>
-              <a:rPr lang="de-DE" dirty="0" err="1"/>
-              <a:t>or</a:t>
-            </a:r>
-            <a:r>
-              <a:rPr lang="de-DE" dirty="0"/>
-              <a:t> </a:t>
-            </a:r>
-            <a:r>
-              <a:rPr lang="de-DE" dirty="0" err="1"/>
-              <a:t>leave</a:t>
-            </a:r>
-            <a:r>
-              <a:rPr lang="de-DE" dirty="0"/>
-              <a:t> </a:t>
-            </a:r>
-            <a:r>
-              <a:rPr lang="de-DE" dirty="0" err="1"/>
-              <a:t>me</a:t>
-            </a:r>
-            <a:r>
-              <a:rPr lang="de-DE" dirty="0"/>
-              <a:t> </a:t>
-            </a:r>
-            <a:r>
-              <a:rPr lang="de-DE" dirty="0" err="1"/>
-              <a:t>alone</a:t>
-            </a:r>
-            <a:r>
-              <a:rPr lang="de-DE" dirty="0"/>
-              <a:t>”: An </a:t>
-            </a:r>
-            <a:r>
-              <a:rPr lang="de-DE" dirty="0" err="1"/>
-              <a:t>intergroup</a:t>
-            </a:r>
-            <a:r>
-              <a:rPr lang="de-DE" dirty="0"/>
-              <a:t> </a:t>
-            </a:r>
-            <a:r>
-              <a:rPr lang="de-DE" dirty="0" err="1"/>
-              <a:t>perspective</a:t>
-            </a:r>
-            <a:r>
-              <a:rPr lang="de-DE" dirty="0"/>
-              <a:t> on </a:t>
-            </a:r>
-            <a:r>
-              <a:rPr lang="de-DE" dirty="0" err="1"/>
-              <a:t>affective</a:t>
-            </a:r>
-            <a:r>
-              <a:rPr lang="de-DE" dirty="0"/>
-              <a:t> </a:t>
-            </a:r>
-            <a:r>
-              <a:rPr lang="de-DE" dirty="0" err="1"/>
-              <a:t>polarization</a:t>
-            </a:r>
-            <a:r>
-              <a:rPr lang="de-DE" dirty="0"/>
-              <a:t> in online </a:t>
-            </a:r>
-            <a:r>
-              <a:rPr lang="de-DE" dirty="0" err="1"/>
-              <a:t>political</a:t>
-            </a:r>
-            <a:r>
-              <a:rPr lang="de-DE" dirty="0"/>
-              <a:t> </a:t>
-            </a:r>
-            <a:r>
-              <a:rPr lang="de-DE" dirty="0" err="1"/>
-              <a:t>discussions</a:t>
-            </a:r>
-            <a:r>
-              <a:rPr lang="de-DE" dirty="0"/>
-              <a:t>. </a:t>
-            </a:r>
-            <a:r>
-              <a:rPr lang="de-DE" i="1" dirty="0"/>
+              <a:rPr lang="en-US" i="1" noProof="0" dirty="0"/>
               <a:t>Communication Research</a:t>
             </a:r>
             <a:r>
-              <a:rPr lang="de-DE" dirty="0"/>
+              <a:rPr lang="en-US" noProof="0" dirty="0"/>
               <a:t>, </a:t>
             </a:r>
             <a:r>
-              <a:rPr lang="de-DE" i="1" dirty="0"/>
+              <a:rPr lang="en-US" i="1" noProof="0" dirty="0"/>
               <a:t>49</a:t>
             </a:r>
             <a:r>
-              <a:rPr lang="de-DE" dirty="0"/>
+              <a:rPr lang="en-US" noProof="0" dirty="0"/>
               <a:t>(3), 376-398.</a:t>
             </a:r>
             <a:br>
-              <a:rPr lang="de-DE" dirty="0"/>
+              <a:rPr lang="en-US" noProof="0" dirty="0"/>
             </a:br>
             <a:br>
-              <a:rPr lang="de-DE" dirty="0"/>
+              <a:rPr lang="en-US" noProof="0" dirty="0"/>
             </a:br>
             <a:r>
-              <a:rPr lang="de-DE" dirty="0" err="1"/>
-              <a:t>Kosmidis</a:t>
+              <a:rPr lang="en-US" noProof="0" dirty="0"/>
+              <a:t>Kosmidis, S., Hobolt, S. B., Molloy, E., &amp; Whitefield, S. (2019). Party competition and emotive rhetoric. </a:t>
             </a:r>
             <a:r>
-              <a:rPr lang="de-DE" dirty="0"/>
-              <a:t>, S., </a:t>
+              <a:rPr lang="en-US" i="1" noProof="0" dirty="0"/>
+              <a:t>Comparative Political Studies</a:t>
             </a:r>
             <a:r>
-              <a:rPr lang="de-DE" dirty="0" err="1"/>
-              <a:t>Hobolt</a:t>
-            </a:r>
-            <a:r>
-              <a:rPr lang="de-DE" dirty="0"/>
-              <a:t>, S. B., Molloy, E., &amp; Whitefield, S. (2019). Party </a:t>
-            </a:r>
-            <a:r>
-              <a:rPr lang="de-DE" dirty="0" err="1"/>
-              <a:t>competition</a:t>
-            </a:r>
-            <a:r>
-              <a:rPr lang="de-DE" dirty="0"/>
-              <a:t> and emotive </a:t>
-            </a:r>
-            <a:r>
-              <a:rPr lang="de-DE" dirty="0" err="1"/>
-              <a:t>rhetoric</a:t>
-            </a:r>
-            <a:r>
-              <a:rPr lang="de-DE" dirty="0"/>
-              <a:t>. </a:t>
-            </a:r>
-            <a:r>
-              <a:rPr lang="de-DE" i="1" dirty="0" err="1"/>
-              <a:t>Comparative</a:t>
-            </a:r>
-            <a:r>
-              <a:rPr lang="de-DE" i="1" dirty="0"/>
-              <a:t> Political Studies</a:t>
-            </a:r>
-            <a:r>
-              <a:rPr lang="de-DE" dirty="0"/>
+              <a:rPr lang="en-US" noProof="0" dirty="0"/>
               <a:t>, </a:t>
             </a:r>
             <a:r>
-              <a:rPr lang="de-DE" i="1" dirty="0"/>
+              <a:rPr lang="en-US" i="1" noProof="0" dirty="0"/>
               <a:t>52</a:t>
             </a:r>
             <a:r>
-              <a:rPr lang="de-DE" dirty="0"/>
+              <a:rPr lang="en-US" noProof="0" dirty="0"/>
               <a:t>(6), 811-837.</a:t>
             </a:r>
           </a:p>
           <a:p>
             <a:pPr marL="228600"/>
-            <a:endParaRPr lang="de-DE" dirty="0"/>
+            <a:endParaRPr lang="en-US" noProof="0" dirty="0"/>
           </a:p>
           <a:p>
             <a:pPr marL="228600"/>
             <a:r>
-              <a:rPr lang="de-DE" dirty="0"/>
-              <a:t>Silva, B. C., Schürmann, L., &amp; Proksch, S. O. (2024). Modulation </a:t>
+              <a:rPr lang="en-US" noProof="0" dirty="0"/>
+              <a:t>Silva, B. C., Schürmann, L., &amp; Proksch, S. O. (2024). Modulation of democracy: Partisan communication during and after election campaigns. </a:t>
             </a:r>
             <a:r>
-              <a:rPr lang="de-DE" dirty="0" err="1"/>
-              <a:t>of</a:t>
+              <a:rPr lang="en-US" i="1" noProof="0" dirty="0"/>
+              <a:t>British Journal of Political Science</a:t>
             </a:r>
             <a:r>
-              <a:rPr lang="de-DE" dirty="0"/>
-              <a:t> </a:t>
-            </a:r>
-            <a:r>
-              <a:rPr lang="de-DE" dirty="0" err="1"/>
-              <a:t>democracy</a:t>
-            </a:r>
-            <a:r>
-              <a:rPr lang="de-DE" dirty="0"/>
-              <a:t>: Partisan </a:t>
-            </a:r>
-            <a:r>
-              <a:rPr lang="de-DE" dirty="0" err="1"/>
-              <a:t>communication</a:t>
-            </a:r>
-            <a:r>
-              <a:rPr lang="de-DE" dirty="0"/>
-              <a:t> </a:t>
-            </a:r>
-            <a:r>
-              <a:rPr lang="de-DE" dirty="0" err="1"/>
-              <a:t>during</a:t>
-            </a:r>
-            <a:r>
-              <a:rPr lang="de-DE" dirty="0"/>
-              <a:t> and after </a:t>
-            </a:r>
-            <a:r>
-              <a:rPr lang="de-DE" dirty="0" err="1"/>
-              <a:t>election</a:t>
-            </a:r>
-            <a:r>
-              <a:rPr lang="de-DE" dirty="0"/>
-              <a:t> </a:t>
-            </a:r>
-            <a:r>
-              <a:rPr lang="de-DE" dirty="0" err="1"/>
-              <a:t>campaigns</a:t>
-            </a:r>
-            <a:r>
-              <a:rPr lang="de-DE" dirty="0"/>
-              <a:t>. </a:t>
-            </a:r>
-            <a:r>
-              <a:rPr lang="de-DE" i="1" dirty="0"/>
-              <a:t>British Journal </a:t>
-            </a:r>
-            <a:r>
-              <a:rPr lang="de-DE" i="1" dirty="0" err="1"/>
-              <a:t>of</a:t>
-            </a:r>
-            <a:r>
-              <a:rPr lang="de-DE" i="1" dirty="0"/>
-              <a:t> Political Science</a:t>
-            </a:r>
-            <a:r>
-              <a:rPr lang="de-DE" dirty="0"/>
+              <a:rPr lang="en-US" noProof="0" dirty="0"/>
               <a:t>, </a:t>
             </a:r>
             <a:r>
-              <a:rPr lang="de-DE" i="1" dirty="0"/>
+              <a:rPr lang="en-US" i="1" noProof="0" dirty="0"/>
               <a:t>54</a:t>
             </a:r>
             <a:r>
-              <a:rPr lang="de-DE" dirty="0"/>
+              <a:rPr lang="en-US" noProof="0" dirty="0"/>
               <a:t>(2), 339-354.</a:t>
             </a:r>
             <a:br>

</xml_diff>